<commit_message>
docs: add group member details to report and presentation
Cover page, plagiarism/AI declaration signature table, contribution table,
deck title slide and per-slide speaker allocation now carry the real names
and student IDs. Lecturer recorded as Dr. Chen.

Co-Authored-By: Claude Opus 5 <noreply@anthropic.com>
</commit_message>
<xml_diff>
--- a/docs/PRESENTATION.pptx
+++ b/docs/PRESENTATION.pptx
@@ -517,7 +517,7 @@
           <a:lstStyle/>
           <a:p>
             <a:r>
-              <a:t>LEADER opens. 30 seconds. Name the theme, the framework, and the one-line claim: a countermeasure unit that analyses deepfake audio, manipulated video and network intrusion in parallel and produces a verified attack vector. Then hand to Member 2.</a:t>
+              <a:t>HARRIS opens. 30 seconds. Name the theme, the framework, and the one-line claim: a countermeasure unit that analyses deepfake audio, manipulated video and network intrusion in parallel and produces a verified attack vector. Then hand to Dharizman.</a:t>
             </a:r>
           </a:p>
         </p:txBody>
@@ -587,7 +587,7 @@
           <a:lstStyle/>
           <a:p>
             <a:r>
-              <a:t>MEMBER 4. Say clearly: these numbers were produced by running demo_fallback.py, and we are about to run it live. That is the bridge into the demo.</a:t>
+              <a:t>NAZRUL AIMAN. Say clearly: these numbers were produced by running demo_fallback.py, and we are about to run it live. That is the bridge into the demo.</a:t>
             </a:r>
           </a:p>
         </p:txBody>
@@ -657,7 +657,7 @@
           <a:lstStyle/>
           <a:p>
             <a:r>
-              <a:t>MEMBER 1 drives the keyboard, MEMBER 2 narrates the trace. Have BOTH scenarios already typed in two terminal tabs. Do not type live. Showing the low-threat run immediately after proves the branch is real and not hard-coded.</a:t>
+              <a:t>HARRIS drives the keyboard, DHARIZMAN narrates the trace. Have BOTH scenarios already typed in two terminal tabs. Do not type live. Showing the low-threat run immediately after proves the branch is real and not hard-coded.</a:t>
             </a:r>
           </a:p>
         </p:txBody>
@@ -727,7 +727,7 @@
           <a:lstStyle/>
           <a:p>
             <a:r>
-              <a:t>MEMBER 4 drives this. This slide covers criterion C4 — a live fallback trigger is separately assessed. If the demo machine misbehaves, the captured output is in Section 5.6 of the report; say so and show it rather than debugging on stage.</a:t>
+              <a:t>NAZRUL AIMAN drives this. This slide covers criterion C4 — a live fallback trigger is separately assessed. If the demo machine misbehaves, the captured output is in Section 5.6 of the report; say so and show it rather than debugging on stage.</a:t>
             </a:r>
           </a:p>
         </p:txBody>
@@ -797,7 +797,7 @@
           <a:lstStyle/>
           <a:p>
             <a:r>
-              <a:t>Any member. The three-scenario table is the proof that routing is input-dependent — different briefs, different dispatch sets, both branches of the escalation gate.</a:t>
+              <a:t>Any member — Azad or Nazrul. The three-scenario table is the proof that routing is input-dependent — different briefs, different dispatch sets, both branches of the escalation gate.</a:t>
             </a:r>
           </a:p>
         </p:txBody>
@@ -867,7 +867,7 @@
           <a:lstStyle/>
           <a:p>
             <a:r>
-              <a:t>Any member — the leader is a good choice. Do NOT downplay AI use; the rubric rewards transparent declaration. The three examples show we understood the code well enough to find real defects in it.</a:t>
+              <a:t>HARRIS or DHARIZMAN. Do NOT downplay AI use; the rubric rewards transparent declaration. The three examples show we understood the code well enough to find real defects in it.</a:t>
             </a:r>
           </a:p>
         </p:txBody>
@@ -937,7 +937,7 @@
           <a:lstStyle/>
           <a:p>
             <a:r>
-              <a:t>LEADER closes. Likely questions: (1) 'Is the router really dynamic?' — yes, semantic classification; the mock engine exists for reproducible grading, and we can re-run against LM Studio. (2) 'What if two agents disagree?' — the coordinator weights by each specialist's reported confidence. (3) 'Why LangGraph over CrewAI?' — bounded execution makes the loop guard and fallback budget enforceable.</a:t>
+              <a:t>HARRIS closes. Likely questions: (1) 'Is the router really dynamic?' — yes, semantic classification; the mock engine exists for reproducible grading, and we can re-run against LM Studio. (2) 'What if two agents disagree?' — the coordinator weights by each specialist's reported confidence. (3) 'Why LangGraph over CrewAI?' — bounded execution makes the loop guard and fallback budget enforceable.</a:t>
             </a:r>
           </a:p>
         </p:txBody>
@@ -1077,7 +1077,7 @@
           <a:lstStyle/>
           <a:p>
             <a:r>
-              <a:t>EVERY member must speak — this is a graded criterion (C1). Fill the bracketed names in before the presentation and rehearse the handovers.</a:t>
+              <a:t>EVERY member must speak — this is a graded criterion (C1). Rehearse the four handovers so they are clean: Harris -&gt; Dharizman -&gt; Azad -&gt; Nazrul, then Harris and Nazrul share the demo.</a:t>
             </a:r>
           </a:p>
         </p:txBody>
@@ -1147,7 +1147,7 @@
           <a:lstStyle/>
           <a:p>
             <a:r>
-              <a:t>MEMBER 1. Keep to 90 seconds. The key line is: the dependency between specialists is real, so the architecture has to express it.</a:t>
+              <a:t>HARRIS. Keep to 90 seconds. The key line is: the dependency between specialists is real, so the architecture has to express it.</a:t>
             </a:r>
           </a:p>
         </p:txBody>
@@ -1217,7 +1217,7 @@
           <a:lstStyle/>
           <a:p>
             <a:r>
-              <a:t>MEMBER 2 starts here. Do NOT read every node. Trace ONE path with your finger: brief → router → two specialists in parallel → coordinator → gate → predictor. Then point at the red path and say 'and that is what happens when it breaks — Member 4 will demo it.'</a:t>
+              <a:t>DHARIZMAN starts here. Do NOT read every node. Trace ONE path with your finger: brief → router → two specialists in parallel → coordinator → gate → predictor. Then point at the red path and say 'and that is what happens when it breaks — Nazrul will demo it.'</a:t>
             </a:r>
           </a:p>
         </p:txBody>
@@ -1287,7 +1287,7 @@
           <a:lstStyle/>
           <a:p>
             <a:r>
-              <a:t>MEMBER 2. This slide answers assessment item A2.2 directly — say the word DYNAMIC out loud. The embedding-model guard is A2.3; mention we test it in the suite.</a:t>
+              <a:t>DHARIZMAN. This slide answers assessment item A2.2 directly — say the word DYNAMIC out loud. The embedding-model guard is A2.3; mention we test it in the suite.</a:t>
             </a:r>
           </a:p>
         </p:txBody>
@@ -1357,7 +1357,7 @@
           <a:lstStyle/>
           <a:p>
             <a:r>
-              <a:t>MEMBER 3 starts here. Emphasise the right-hand column — what each agent is FORBIDDEN from doing. That is what stops three agents reporting the same piece of evidence as if it were three corroborating sources.</a:t>
+              <a:t>AZAD ARIF starts here. Emphasise the right-hand column — what each agent is FORBIDDEN from doing. That is what stops three agents reporting the same piece of evidence as if it were three corroborating sources.</a:t>
             </a:r>
           </a:p>
         </p:txBody>
@@ -1427,7 +1427,7 @@
           <a:lstStyle/>
           <a:p>
             <a:r>
-              <a:t>MEMBER 3. This is the highest-value slide for the 'Prompt Engineering' rubric row (15%). Tell the failure story — examiners remember the always-SYNTHETIC bug. 12 prompt iterations are logged in Section 3.4 of the report.</a:t>
+              <a:t>AZAD ARIF. This is the highest-value slide for the 'Prompt Engineering' rubric row (15%). Tell the failure story — examiners remember the always-SYNTHETIC bug. 12 prompt iterations are logged in Section 3.4 of the report.</a:t>
             </a:r>
           </a:p>
         </p:txBody>
@@ -1497,7 +1497,7 @@
           <a:lstStyle/>
           <a:p>
             <a:r>
-              <a:t>MEMBER 2 or 3. Rubric asks us to JUSTIFY the pattern over alternatives — so name all three alternatives and give the one-line reason each was rejected. Do not skip this slide.</a:t>
+              <a:t>DHARIZMAN or AZAD. Rubric asks us to JUSTIFY the pattern over alternatives — so name all three alternatives and give the one-line reason each was rejected. Do not skip this slide.</a:t>
             </a:r>
           </a:p>
         </p:txBody>
@@ -1567,7 +1567,7 @@
           <a:lstStyle/>
           <a:p>
             <a:r>
-              <a:t>MEMBER 4 starts here. The 'exclude, don't zero' point is the strongest single line in this section — a failed audio agent must not make the incident look safer than it is.</a:t>
+              <a:t>NAZRUL AIMAN starts here. The 'exclude, don't zero' point is the strongest single line in this section — a failed audio agent must not make the incident look safer than it is.</a:t>
             </a:r>
           </a:p>
         </p:txBody>
@@ -4913,36 +4913,36 @@
         </p:nvSpPr>
         <p:spPr>
           <a:xfrm>
-            <a:off x="914400" y="5532120"/>
-            <a:ext cx="10332720" cy="822960"/>
-          </a:xfrm>
-          <a:prstGeom prst="rect">
-            <a:avLst/>
-          </a:prstGeom>
-          <a:noFill/>
-        </p:spPr>
-        <p:txBody>
-          <a:bodyPr wrap="square" lIns="0" rIns="0" tIns="0" bIns="0">
-            <a:spAutoFit/>
-          </a:bodyPr>
-          <a:lstStyle/>
-          <a:p>
-            <a:pPr algn="l">
-              <a:lnSpc>
-                <a:spcPct val="115000"/>
-              </a:lnSpc>
-              <a:spcAft>
-                <a:spcPts val="600"/>
-              </a:spcAft>
-            </a:pPr>
-            <a:r>
-              <a:rPr sz="1400" b="1">
+            <a:off x="914400" y="5440680"/>
+            <a:ext cx="10332720" cy="640080"/>
+          </a:xfrm>
+          <a:prstGeom prst="rect">
+            <a:avLst/>
+          </a:prstGeom>
+          <a:noFill/>
+        </p:spPr>
+        <p:txBody>
+          <a:bodyPr wrap="square" lIns="0" rIns="0" tIns="0" bIns="0">
+            <a:spAutoFit/>
+          </a:bodyPr>
+          <a:lstStyle/>
+          <a:p>
+            <a:pPr algn="l">
+              <a:lnSpc>
+                <a:spcPct val="135000"/>
+              </a:lnSpc>
+              <a:spcAft>
+                <a:spcPts val="600"/>
+              </a:spcAft>
+            </a:pPr>
+            <a:r>
+              <a:rPr sz="1150" b="1">
                 <a:solidFill>
                   <a:srgbClr val="FFFFFF"/>
                 </a:solidFill>
                 <a:latin typeface="Segoe UI"/>
               </a:rPr>
-              <a:t>[Member 1 — Leader]     [Member 2]     [Member 3]     [Member 4]</a:t>
+              <a:t>HARRIS ILHAM SHAH BIN MOHD AZRAF  (Leader)  ·  52213125949          DHARIZMAN BIN GHAZALI @ HASSAN  ·  52213125618</a:t>
             </a:r>
           </a:p>
         </p:txBody>
@@ -4955,7 +4955,49 @@
         </p:nvSpPr>
         <p:spPr>
           <a:xfrm>
-            <a:off x="914400" y="5897880"/>
+            <a:off x="914400" y="5833872"/>
+            <a:ext cx="10332720" cy="640080"/>
+          </a:xfrm>
+          <a:prstGeom prst="rect">
+            <a:avLst/>
+          </a:prstGeom>
+          <a:noFill/>
+        </p:spPr>
+        <p:txBody>
+          <a:bodyPr wrap="square" lIns="0" rIns="0" tIns="0" bIns="0">
+            <a:spAutoFit/>
+          </a:bodyPr>
+          <a:lstStyle/>
+          <a:p>
+            <a:pPr algn="l">
+              <a:lnSpc>
+                <a:spcPct val="135000"/>
+              </a:lnSpc>
+              <a:spcAft>
+                <a:spcPts val="600"/>
+              </a:spcAft>
+            </a:pPr>
+            <a:r>
+              <a:rPr sz="1150" b="1">
+                <a:solidFill>
+                  <a:srgbClr val="FFFFFF"/>
+                </a:solidFill>
+                <a:latin typeface="Segoe UI"/>
+              </a:rPr>
+              <a:t>AZAD ARIF BIN ABDUL RAZAK  ·  52213125884          MUHAMMAD NAZRUL AIMAN BIN MOHD NIZAM  ·  52213124200</a:t>
+            </a:r>
+          </a:p>
+        </p:txBody>
+      </p:sp>
+      <p:sp>
+        <p:nvSpPr>
+          <p:cNvPr id="11" name="TextBox 10"/>
+          <p:cNvSpPr txBox="1"/>
+          <p:nvPr/>
+        </p:nvSpPr>
+        <p:spPr>
+          <a:xfrm>
+            <a:off x="914400" y="6263640"/>
             <a:ext cx="10332720" cy="365760"/>
           </a:xfrm>
           <a:prstGeom prst="rect">
@@ -4978,13 +5020,13 @@
               </a:spcAft>
             </a:pPr>
             <a:r>
-              <a:rPr sz="1150" b="0">
+              <a:rPr sz="1100" b="0">
                 <a:solidFill>
                   <a:srgbClr val="94A3B8"/>
                 </a:solidFill>
                 <a:latin typeface="Segoe UI"/>
               </a:rPr>
-              <a:t>Malaysian Institute of Information Technology  ·  Week 7</a:t>
+              <a:t>Lecturer: Dr. Chen  ·  Malaysian Institute of Information Technology  ·  Week 7</a:t>
             </a:r>
           </a:p>
         </p:txBody>
@@ -12677,7 +12719,7 @@
                 </a:solidFill>
                 <a:latin typeface="Segoe UI"/>
               </a:rPr>
-              <a:t>[Member 1 — Leader]</a:t>
+              <a:t>HARRIS</a:t>
             </a:r>
           </a:p>
         </p:txBody>
@@ -12847,7 +12889,7 @@
                 </a:solidFill>
                 <a:latin typeface="Segoe UI"/>
               </a:rPr>
-              <a:t>[Member 2]</a:t>
+              <a:t>DHARIZMAN</a:t>
             </a:r>
           </a:p>
         </p:txBody>
@@ -13017,7 +13059,7 @@
                 </a:solidFill>
                 <a:latin typeface="Segoe UI"/>
               </a:rPr>
-              <a:t>[Member 3]</a:t>
+              <a:t>AZAD ARIF</a:t>
             </a:r>
           </a:p>
         </p:txBody>
@@ -13187,7 +13229,7 @@
                 </a:solidFill>
                 <a:latin typeface="Segoe UI"/>
               </a:rPr>
-              <a:t>[Member 4]</a:t>
+              <a:t>NAZRUL AIMAN</a:t>
             </a:r>
           </a:p>
         </p:txBody>
@@ -13357,7 +13399,7 @@
                 </a:solidFill>
                 <a:latin typeface="Segoe UI"/>
               </a:rPr>
-              <a:t>[Member 1 + 4]</a:t>
+              <a:t>HARRIS + NAZRUL</a:t>
             </a:r>
           </a:p>
         </p:txBody>
@@ -13527,7 +13569,7 @@
                 </a:solidFill>
                 <a:latin typeface="Segoe UI"/>
               </a:rPr>
-              <a:t>All members</a:t>
+              <a:t>All four members</a:t>
             </a:r>
           </a:p>
         </p:txBody>

</xml_diff>